<commit_message>
Requirements Engineering: ArenaOne Spezifikation v0.7 (Kernprozess ohne Self-Service), Leitfaden mit Muss-Fragen, Bestätigungsliste
</commit_message>
<xml_diff>
--- a/requirements-engineering/re-arenaone/praesentation-pva9-10/RE_ArenaOne_Zwischenstand_PVA6.pptx
+++ b/requirements-engineering/re-arenaone/praesentation-pva9-10/RE_ArenaOne_Zwischenstand_PVA6.pptx
@@ -109,7 +109,7 @@
   <p:extLst>
     <p:ext uri="{521415D9-36F7-43E2-AB2F-B90AF26B5E84}">
       <p14:sectionLst xmlns:p14="http://schemas.microsoft.com/office/powerpoint/2010/main">
-        <p14:section name="Zwischenstand" id="{c6b2d598-6a89-14a3-534d-a74feeb51da5}">
+        <p14:section name="Zwischenstand" id="{0abf8cdd-20dd-f977-b5e3-b653c2ca1cde}">
           <p14:sldIdLst>
             <p14:sldId id="256"/>
             <p14:sldId id="257"/>
@@ -521,7 +521,7 @@
             <a:r>
               <a:rPr lang="en-US" dirty="0"/>
               <a:t>⏱ 1:00 · Görkem Taspinar
-Wir sind Gruppe 9 und machen das Requirements Engineering für ArenaOne. Wir arbeiten nach dem Kreislauf von Folie 28. Die erste Runde ist abgeschlossen: Wir haben die Präsentation von Gruppe 2 analysiert, das Interview im Team als Rollenspiel geprobt und daraus die Spezifikation v0.6 geschrieben und intern geprüft. Was noch fehlt, ist das Wichtigste: die Validierung mit Gruppe 2. Damit beginnt die zweite Runde.
+Wir sind Gruppe 9 und machen das Requirements Engineering für ArenaOne. Wir arbeiten nach dem Kreislauf von Folie 28. Die erste Runde ist abgeschlossen: Wir haben die Präsentation von Gruppe 2 analysiert, das Interview im Team als Rollenspiel geprobt und daraus die Spezifikation v0.7 geschrieben und intern geprüft. Was noch fehlt, ist das Wichtigste: die Validierung mit Gruppe 2. Damit beginnt die zweite Runde.
 [Vor PVA 6 an den echten Stand anpassen.]</a:t>
             </a:r>
             <a:endParaRPr lang="en-US" dirty="0"/>
@@ -611,7 +611,7 @@
             <a:r>
               <a:rPr lang="en-US" dirty="0"/>
               <a:t>⏱ 1:00 · Ardian Ibrahimaj
-In Zahlen: 12 Stakeholder, 9 Use Cases, 35 funktionale und 16 Qualitätsanforderungen. Jede Anforderung hat eine Quelle. 39 gehen auf Folien von Gruppe 2 zurück, 12 nur auf Annahmen, das Gesetz, den Benchmark oder unseren Probelauf. Die prüfen wir mit Gruppe 2 zuerst. Dafür haben wir 22 offene Punkte.</a:t>
+In Zahlen: 12 Stakeholder, 9 Use Cases, 37 funktionale und 16 Qualitätsanforderungen. Jede Anforderung hat eine Quelle. 41 gehen auf Folien von Gruppe 2 zurück, 12 nur auf Annahmen, das Gesetz, den Benchmark oder unseren Probelauf. Die prüfen wir mit Gruppe 2 zuerst. Dafür haben wir 22 offene Punkte.</a:t>
             </a:r>
             <a:endParaRPr lang="en-US" dirty="0"/>
           </a:p>
@@ -700,7 +700,7 @@
             <a:r>
               <a:rPr lang="en-US" dirty="0"/>
               <a:t>⏱ 1:00 · Görkem Taspinar
-Drei Dinge haben uns überrascht. Erstens: Self-Service ist gar nicht verlangt – diese Frage entscheidet über den Umfang. Zweitens: In den Serien stecken versteckte Anforderungen, etwa das Absagen einzelner Termine. Drittens: Die eigentlichen Konflikte, etwa wer abends spielen darf, können wir nur vorbereiten – entscheiden muss die Geschäftsleitung. Bis PVA 9/10 werten wir das Interview aus, lassen die Spezifikation reviewen und priorisieren, spielen Szenarien durch und holen die Freigabe. Für den Erfahrungsaustausch eine Frage an alle: Wie bringt ihr euren Auftraggeber dazu, Zahlen zu nennen?</a:t>
+Drei Dinge haben uns überrascht. Erstens: Self-Service ist gar nicht verlangt – darum läuft unser Kernprozess über den Empfang, und online selbst buchen ist nur eine Variante. Diese Frage entscheidet über den Umfang. Zweitens: In den Serien stecken versteckte Anforderungen, etwa das Absagen einzelner Termine. Drittens: Die eigentlichen Konflikte, etwa wer abends spielen darf, können wir nur vorbereiten – entscheiden muss die Geschäftsleitung. Bis PVA 9/10 werten wir das Interview aus, lassen Gruppe 2 unsere Annahmen schriftlich bestätigen, lassen die Spezifikation reviewen und priorisieren, spielen Szenarien durch und holen die Freigabe. Für den Erfahrungsaustausch eine Frage an alle: Wie bringt ihr euren Auftraggeber dazu, Zahlen zu nennen?</a:t>
             </a:r>
             <a:endParaRPr lang="en-US" dirty="0"/>
           </a:p>
@@ -975,7 +975,7 @@
                   <a:schemeClr val="tx2"/>
                 </a:solidFill>
               </a:rPr>
-              <a:t>ArenaOne Sportzentrum AG (fiktiv) · RE Gruppe 9 · Zwischenstand PVA 6 · Spezifikation v0.6</a:t>
+              <a:t>ArenaOne Sportzentrum AG (fiktiv) · RE Gruppe 9 · Zwischenstand PVA 6 · Spezifikation v0.7</a:t>
             </a:r>
             <a:endParaRPr lang="en-US" sz="1000" dirty="0"/>
           </a:p>
@@ -1763,7 +1763,7 @@
                   <a:schemeClr val="tx2"/>
                 </a:solidFill>
               </a:rPr>
-              <a:t>Spezifikation v0.6</a:t>
+              <a:t>Spezifikation v0.7</a:t>
             </a:r>
             <a:endParaRPr lang="en-US" sz="1300" dirty="0"/>
           </a:p>
@@ -2238,7 +2238,7 @@
                   <a:schemeClr val="tx1"/>
                 </a:solidFill>
               </a:rPr>
-              <a:t>Erste Runde ohne Gruppe 2 abgeschlossen – Analyse der Präsentation, Probelauf des Interviews, Spezifikation v0.6 intern geprüft. </a:t>
+              <a:t>Erste Runde ohne Gruppe 2 abgeschlossen – Analyse der Präsentation, Probelauf des Interviews, Spezifikation v0.7 intern geprüft. </a:t>
             </a:r>
             <a:pPr indent="0" marL="0">
               <a:buNone/>
@@ -2307,7 +2307,7 @@
                   <a:schemeClr val="tx2"/>
                 </a:solidFill>
               </a:rPr>
-              <a:t>[Vor PVA 6 aktualisieren: Hat das Interview PVA 5 stattgefunden, steht «Validieren» auf «läuft» und die Version auf v0.7.]</a:t>
+              <a:t>[Vor PVA 6 aktualisieren: Nach Interview und Bestätigungsliste steht «Validieren» auf «läuft» und die Version auf v0.8.]</a:t>
             </a:r>
             <a:endParaRPr lang="en-US" sz="1100" dirty="0"/>
           </a:p>
@@ -2453,7 +2453,7 @@
                   <a:schemeClr val="tx1"/>
                 </a:solidFill>
               </a:rPr>
-              <a:t>51 Anforderungen – jede mit Quelle</a:t>
+              <a:t>53 Anforderungen – jede mit Quelle</a:t>
             </a:r>
             <a:endParaRPr lang="en-US" sz="3200" dirty="0"/>
           </a:p>
@@ -2491,7 +2491,7 @@
                   <a:schemeClr val="tx2"/>
                 </a:solidFill>
               </a:rPr>
-              <a:t>Stand Spezifikation v0.6; Zahlen aus der Nachverfolgbarkeitsmatrix.</a:t>
+              <a:t>Stand Spezifikation v0.7; Zahlen aus der Nachverfolgbarkeitsmatrix.</a:t>
             </a:r>
             <a:endParaRPr lang="en-US" sz="1600" dirty="0"/>
           </a:p>
@@ -2809,7 +2809,7 @@
                   <a:schemeClr val="accent1"/>
                 </a:solidFill>
               </a:rPr>
-              <a:t>35</a:t>
+              <a:t>37</a:t>
             </a:r>
             <a:endParaRPr lang="en-US" sz="4600" dirty="0"/>
           </a:p>
@@ -2881,7 +2881,7 @@
                   <a:schemeClr val="tx2"/>
                 </a:solidFill>
               </a:rPr>
-              <a:t>davon 21 Must</a:t>
+              <a:t>davon 20 Must</a:t>
             </a:r>
             <a:endParaRPr lang="en-US" sz="1200" dirty="0"/>
           </a:p>
@@ -3206,7 +3206,7 @@
         <p:spPr>
           <a:xfrm>
             <a:off x="548640" y="4709160"/>
-            <a:ext cx="8483965" cy="411480"/>
+            <a:ext cx="8582472" cy="411480"/>
           </a:xfrm>
           <a:prstGeom prst="rect">
             <a:avLst/>
@@ -3225,8 +3225,8 @@
         </p:nvSpPr>
         <p:spPr>
           <a:xfrm>
-            <a:off x="9032605" y="4709160"/>
-            <a:ext cx="2610451" cy="411480"/>
+            <a:off x="9131112" y="4709160"/>
+            <a:ext cx="2511943" cy="411480"/>
           </a:xfrm>
           <a:prstGeom prst="rect">
             <a:avLst/>
@@ -3246,7 +3246,7 @@
         <p:spPr>
           <a:xfrm>
             <a:off x="731520" y="4709160"/>
-            <a:ext cx="8118205" cy="411480"/>
+            <a:ext cx="8216712" cy="411480"/>
           </a:xfrm>
           <a:prstGeom prst="rect">
             <a:avLst/>
@@ -3267,7 +3267,7 @@
                   <a:schemeClr val="bg1"/>
                 </a:solidFill>
               </a:rPr>
-              <a:t>39 mit Folie oder Notiz von Gruppe 2 belegt</a:t>
+              <a:t>41 mit Folie oder Notiz von Gruppe 2 belegt</a:t>
             </a:r>
             <a:endParaRPr lang="en-US" sz="1400" dirty="0"/>
           </a:p>
@@ -3281,8 +3281,8 @@
         </p:nvSpPr>
         <p:spPr>
           <a:xfrm>
-            <a:off x="9124045" y="4709160"/>
-            <a:ext cx="2427571" cy="411480"/>
+            <a:off x="9222552" y="4709160"/>
+            <a:ext cx="2329063" cy="411480"/>
           </a:xfrm>
           <a:prstGeom prst="rect">
             <a:avLst/>
@@ -3601,7 +3601,7 @@
                   <a:schemeClr val="tx2"/>
                 </a:solidFill>
               </a:rPr>
-              <a:t>Gruppe 2 nennt «komfortabler für Kunden», aber nicht, dass Kunden selbst online reservieren. Diese eine Antwort verändert den Umfang am stärksten (OP-02).</a:t>
+              <a:t>Darum läuft unser Kernprozess über den Empfang; online selbst buchen ist eine Variante (Should). Die Antwort darauf verändert den Umfang am stärksten (OP-02).</a:t>
             </a:r>
             <a:endParaRPr lang="en-US" sz="1400" dirty="0"/>
           </a:p>
@@ -3829,7 +3829,7 @@
                   <a:schemeClr val="tx1"/>
                 </a:solidFill>
               </a:rPr>
-              <a:t>Interview mit Gruppe 2 auswerten, Spezifikation v0.7</a:t>
+              <a:t>Interview auswerten, Annahmen von Gruppe 2 bestätigen lassen</a:t>
             </a:r>
             <a:endParaRPr lang="en-US" sz="1500" dirty="0"/>
           </a:p>
@@ -3921,7 +3921,7 @@
                   <a:schemeClr val="tx1"/>
                 </a:solidFill>
               </a:rPr>
-              <a:t>Review der Spezifikation durch Gruppe 2</a:t>
+              <a:t>Spezifikation v0.8, Review durch Gruppe 2</a:t>
             </a:r>
             <a:endParaRPr lang="en-US" sz="1500" dirty="0"/>
           </a:p>

</xml_diff>